<commit_message>
sd-02-021: TV on the deck's glossary slide
Co-Authored-By: Claude Opus 5.5 <noreply@anthropic.com>
Claude-Session: https://claude.ai/code/session_01McBLtMnJbTnB94NeVs8a2V
</commit_message>
<xml_diff>
--- a/system-design-101/vi/lessons/sd-02-021/slides/sd-02-021.pptx
+++ b/system-design-101/vi/lessons/sd-02-021/slides/sd-02-021.pptx
@@ -2969,7 +2969,7 @@
                 <a:gridCol w="6254496"/>
                 <a:gridCol w="7900416"/>
               </a:tblGrid>
-              <a:tr h="876300">
+              <a:tr h="800100">
                 <a:tc>
                   <a:txBody>
                     <a:bodyPr/>
@@ -3168,7 +3168,7 @@
                   </a:tcPr>
                 </a:tc>
               </a:tr>
-              <a:tr h="876300">
+              <a:tr h="800100">
                 <a:tc>
                   <a:txBody>
                     <a:bodyPr/>
@@ -3407,7 +3407,7 @@
                   </a:tcPr>
                 </a:tc>
               </a:tr>
-              <a:tr h="876300">
+              <a:tr h="800100">
                 <a:tc>
                   <a:txBody>
                     <a:bodyPr/>
@@ -3657,7 +3657,235 @@
                   </a:tcPr>
                 </a:tc>
               </a:tr>
-              <a:tr h="876300">
+              <a:tr h="800100">
+                <a:tc>
+                  <a:txBody>
+                    <a:bodyPr/>
+                    <a:lstStyle/>
+                    <a:p>
+                      <a:pPr algn="l" indent="0" marL="0">
+                        <a:lnSpc>
+                          <a:spcPts val="2700"/>
+                        </a:lnSpc>
+                        <a:buNone/>
+                      </a:pPr>
+                      <a:r>
+                        <a:rPr lang="en-US" sz="2250" dirty="0" kern="0">
+                          <a:solidFill>
+                            <a:srgbClr val="3DD6A0"/>
+                          </a:solidFill>
+                          <a:latin typeface="Be Vietnam Pro" pitchFamily="34" charset="0"/>
+                          <a:ea typeface="Be Vietnam Pro" pitchFamily="34" charset="-122"/>
+                          <a:cs typeface="Be Vietnam Pro" pitchFamily="34" charset="-120"/>
+                        </a:rPr>
+                        <a:t>TV</a:t>
+                      </a:r>
+                      <a:endParaRPr lang="en-US" sz="1200" dirty="0"/>
+                    </a:p>
+                  </a:txBody>
+                  <a:tcPr marL="76200" marR="76200" marT="76200" marB="76200">
+                    <a:lnL w="9525" cap="flat" cmpd="sng" algn="ctr">
+                      <a:solidFill>
+                        <a:srgbClr val="2D3140"/>
+                      </a:solidFill>
+                      <a:prstDash val="solid"/>
+                      <a:round/>
+                      <a:headEnd type="none" w="med" len="med"/>
+                      <a:tailEnd type="none" w="med" len="med"/>
+                    </a:lnL>
+                    <a:lnR w="0" cap="flat" cmpd="sng" algn="ctr">
+                      <a:noFill/>
+                    </a:lnR>
+                    <a:lnT w="9525" cap="flat" cmpd="sng" algn="ctr">
+                      <a:solidFill>
+                        <a:srgbClr val="2D3140"/>
+                      </a:solidFill>
+                      <a:prstDash val="solid"/>
+                      <a:round/>
+                      <a:headEnd type="none" w="med" len="med"/>
+                      <a:tailEnd type="none" w="med" len="med"/>
+                    </a:lnT>
+                    <a:lnB w="0" cap="flat" cmpd="sng" algn="ctr">
+                      <a:noFill/>
+                    </a:lnB>
+                    <a:solidFill>
+                      <a:srgbClr val="1A1D25"/>
+                    </a:solidFill>
+                  </a:tcPr>
+                </a:tc>
+                <a:tc>
+                  <a:txBody>
+                    <a:bodyPr/>
+                    <a:lstStyle/>
+                    <a:p>
+                      <a:pPr algn="l" indent="0" marL="0">
+                        <a:lnSpc>
+                          <a:spcPts val="2700"/>
+                        </a:lnSpc>
+                        <a:buNone/>
+                      </a:pPr>
+                      <a:r>
+                        <a:rPr lang="en-US" sz="2250" dirty="0" spc="-30" kern="0">
+                          <a:solidFill>
+                            <a:srgbClr val="E4E1D8"/>
+                          </a:solidFill>
+                          <a:latin typeface="Be Vietnam Pro" pitchFamily="34" charset="0"/>
+                          <a:ea typeface="Be Vietnam Pro" pitchFamily="34" charset="-122"/>
+                          <a:cs typeface="Be Vietnam Pro" pitchFamily="34" charset="-120"/>
+                        </a:rPr>
+                        <a:t>TeleVision</a:t>
+                      </a:r>
+                      <a:endParaRPr lang="en-US" sz="1200" dirty="0"/>
+                    </a:p>
+                  </a:txBody>
+                  <a:tcPr marL="76200" marR="76200" marT="76200" marB="76200">
+                    <a:lnL w="9525" cap="flat" cmpd="sng" algn="ctr">
+                      <a:solidFill>
+                        <a:srgbClr val="2D3140"/>
+                      </a:solidFill>
+                      <a:prstDash val="solid"/>
+                      <a:round/>
+                      <a:headEnd type="none" w="med" len="med"/>
+                      <a:tailEnd type="none" w="med" len="med"/>
+                    </a:lnL>
+                    <a:lnR w="0" cap="flat" cmpd="sng" algn="ctr">
+                      <a:noFill/>
+                    </a:lnR>
+                    <a:lnT w="9525" cap="flat" cmpd="sng" algn="ctr">
+                      <a:solidFill>
+                        <a:srgbClr val="2D3140"/>
+                      </a:solidFill>
+                      <a:prstDash val="solid"/>
+                      <a:round/>
+                      <a:headEnd type="none" w="med" len="med"/>
+                      <a:tailEnd type="none" w="med" len="med"/>
+                    </a:lnT>
+                    <a:lnB w="0" cap="flat" cmpd="sng" algn="ctr">
+                      <a:noFill/>
+                    </a:lnB>
+                    <a:solidFill>
+                      <a:srgbClr val="1A1D25"/>
+                    </a:solidFill>
+                  </a:tcPr>
+                </a:tc>
+                <a:tc>
+                  <a:txBody>
+                    <a:bodyPr/>
+                    <a:lstStyle/>
+                    <a:p>
+                      <a:pPr algn="l" indent="0" marL="0">
+                        <a:lnSpc>
+                          <a:spcPts val="2700"/>
+                        </a:lnSpc>
+                        <a:buNone/>
+                      </a:pPr>
+                      <a:r>
+                        <a:rPr lang="en-US" sz="2250" dirty="0" spc="-4" kern="0">
+                          <a:solidFill>
+                            <a:srgbClr val="E4E1D8"/>
+                          </a:solidFill>
+                          <a:latin typeface="Be Vietnam Pro" pitchFamily="34" charset="0"/>
+                          <a:ea typeface="Be Vietnam Pro" pitchFamily="34" charset="-122"/>
+                          <a:cs typeface="Be Vietnam Pro" pitchFamily="34" charset="-120"/>
+                        </a:rPr>
+                        <a:t>tivi,</a:t>
+                      </a:r>
+                      <a:r>
+                        <a:rPr lang="en-US" sz="2250" dirty="0" spc="24" kern="0">
+                          <a:solidFill>
+                            <a:srgbClr val="E4E1D8"/>
+                          </a:solidFill>
+                          <a:latin typeface="Be Vietnam Pro" pitchFamily="34" charset="0"/>
+                          <a:ea typeface="Be Vietnam Pro" pitchFamily="34" charset="-122"/>
+                          <a:cs typeface="Be Vietnam Pro" pitchFamily="34" charset="-120"/>
+                        </a:rPr>
+                        <a:t> ứng</a:t>
+                      </a:r>
+                      <a:r>
+                        <a:rPr lang="en-US" sz="2250" dirty="0" spc="3" kern="0">
+                          <a:solidFill>
+                            <a:srgbClr val="E4E1D8"/>
+                          </a:solidFill>
+                          <a:latin typeface="Be Vietnam Pro" pitchFamily="34" charset="0"/>
+                          <a:ea typeface="Be Vietnam Pro" pitchFamily="34" charset="-122"/>
+                          <a:cs typeface="Be Vietnam Pro" pitchFamily="34" charset="-120"/>
+                        </a:rPr>
+                        <a:t> dụng</a:t>
+                      </a:r>
+                      <a:r>
+                        <a:rPr lang="en-US" sz="2250" dirty="0" spc="-15" kern="0">
+                          <a:solidFill>
+                            <a:srgbClr val="E4E1D8"/>
+                          </a:solidFill>
+                          <a:latin typeface="Be Vietnam Pro" pitchFamily="34" charset="0"/>
+                          <a:ea typeface="Be Vietnam Pro" pitchFamily="34" charset="-122"/>
+                          <a:cs typeface="Be Vietnam Pro" pitchFamily="34" charset="-120"/>
+                        </a:rPr>
+                        <a:t> Netflix</a:t>
+                      </a:r>
+                      <a:r>
+                        <a:rPr lang="en-US" sz="2250" dirty="0" spc="-19" kern="0">
+                          <a:solidFill>
+                            <a:srgbClr val="E4E1D8"/>
+                          </a:solidFill>
+                          <a:latin typeface="Be Vietnam Pro" pitchFamily="34" charset="0"/>
+                          <a:ea typeface="Be Vietnam Pro" pitchFamily="34" charset="-122"/>
+                          <a:cs typeface="Be Vietnam Pro" pitchFamily="34" charset="-120"/>
+                        </a:rPr>
+                        <a:t> trên</a:t>
+                      </a:r>
+                      <a:r>
+                        <a:rPr lang="en-US" sz="2250" dirty="0" spc="-2" kern="0">
+                          <a:solidFill>
+                            <a:srgbClr val="E4E1D8"/>
+                          </a:solidFill>
+                          <a:latin typeface="Be Vietnam Pro" pitchFamily="34" charset="0"/>
+                          <a:ea typeface="Be Vietnam Pro" pitchFamily="34" charset="-122"/>
+                          <a:cs typeface="Be Vietnam Pro" pitchFamily="34" charset="-120"/>
+                        </a:rPr>
+                        <a:t> tivi</a:t>
+                      </a:r>
+                      <a:endParaRPr lang="en-US" sz="1200" dirty="0"/>
+                    </a:p>
+                  </a:txBody>
+                  <a:tcPr marL="76200" marR="76200" marT="76200" marB="76200">
+                    <a:lnL w="9525" cap="flat" cmpd="sng" algn="ctr">
+                      <a:solidFill>
+                        <a:srgbClr val="2D3140"/>
+                      </a:solidFill>
+                      <a:prstDash val="solid"/>
+                      <a:round/>
+                      <a:headEnd type="none" w="med" len="med"/>
+                      <a:tailEnd type="none" w="med" len="med"/>
+                    </a:lnL>
+                    <a:lnR w="9525" cap="flat" cmpd="sng" algn="ctr">
+                      <a:solidFill>
+                        <a:srgbClr val="2D3140"/>
+                      </a:solidFill>
+                      <a:prstDash val="solid"/>
+                      <a:round/>
+                      <a:headEnd type="none" w="med" len="med"/>
+                      <a:tailEnd type="none" w="med" len="med"/>
+                    </a:lnR>
+                    <a:lnT w="9525" cap="flat" cmpd="sng" algn="ctr">
+                      <a:solidFill>
+                        <a:srgbClr val="2D3140"/>
+                      </a:solidFill>
+                      <a:prstDash val="solid"/>
+                      <a:round/>
+                      <a:headEnd type="none" w="med" len="med"/>
+                      <a:tailEnd type="none" w="med" len="med"/>
+                    </a:lnT>
+                    <a:lnB w="0" cap="flat" cmpd="sng" algn="ctr">
+                      <a:noFill/>
+                    </a:lnB>
+                    <a:solidFill>
+                      <a:srgbClr val="1A1D25"/>
+                    </a:solidFill>
+                  </a:tcPr>
+                </a:tc>
+              </a:tr>
+              <a:tr h="800100">
                 <a:tc>
                   <a:txBody>
                     <a:bodyPr/>
@@ -3709,7 +3937,7 @@
                       <a:noFill/>
                     </a:lnB>
                     <a:solidFill>
-                      <a:srgbClr val="1A1D25"/>
+                      <a:srgbClr val="14161C"/>
                     </a:solidFill>
                   </a:tcPr>
                 </a:tc>
@@ -3775,7 +4003,7 @@
                       <a:noFill/>
                     </a:lnB>
                     <a:solidFill>
-                      <a:srgbClr val="1A1D25"/>
+                      <a:srgbClr val="14161C"/>
                     </a:solidFill>
                   </a:tcPr>
                 </a:tc>
@@ -3869,12 +4097,12 @@
                       <a:noFill/>
                     </a:lnB>
                     <a:solidFill>
-                      <a:srgbClr val="1A1D25"/>
+                      <a:srgbClr val="14161C"/>
                     </a:solidFill>
                   </a:tcPr>
                 </a:tc>
               </a:tr>
-              <a:tr h="876300">
+              <a:tr h="800100">
                 <a:tc>
                   <a:txBody>
                     <a:bodyPr/>
@@ -3926,7 +4154,7 @@
                       <a:noFill/>
                     </a:lnB>
                     <a:solidFill>
-                      <a:srgbClr val="14161C"/>
+                      <a:srgbClr val="1A1D25"/>
                     </a:solidFill>
                   </a:tcPr>
                 </a:tc>
@@ -3992,7 +4220,7 @@
                       <a:noFill/>
                     </a:lnB>
                     <a:solidFill>
-                      <a:srgbClr val="14161C"/>
+                      <a:srgbClr val="1A1D25"/>
                     </a:solidFill>
                   </a:tcPr>
                 </a:tc>
@@ -4108,7 +4336,7 @@
                       <a:noFill/>
                     </a:lnB>
                     <a:solidFill>
-                      <a:srgbClr val="14161C"/>
+                      <a:srgbClr val="1A1D25"/>
                     </a:solidFill>
                   </a:tcPr>
                 </a:tc>
@@ -4125,7 +4353,7 @@
         </p:nvSpPr>
         <p:spPr>
           <a:xfrm>
-            <a:off x="914400" y="7239000"/>
+            <a:off x="914400" y="7677150"/>
             <a:ext cx="11430000" cy="428625"/>
           </a:xfrm>
           <a:prstGeom prst="rect">
@@ -4175,7 +4403,7 @@
         </p:nvSpPr>
         <p:spPr>
           <a:xfrm>
-            <a:off x="914400" y="7658100"/>
+            <a:off x="914400" y="8096250"/>
             <a:ext cx="16459200" cy="552450"/>
           </a:xfrm>
           <a:prstGeom prst="rect">
@@ -4291,7 +4519,7 @@
         </p:nvSpPr>
         <p:spPr>
           <a:xfrm>
-            <a:off x="914400" y="8191500"/>
+            <a:off x="914400" y="8629650"/>
             <a:ext cx="16459200" cy="390525"/>
           </a:xfrm>
           <a:prstGeom prst="rect">

</xml_diff>

<commit_message>
sd-02-021: the one-shape gateway is an assumption; the real cost is client logic piling into one gateway
Co-Authored-By: Claude Opus 5.5 <noreply@anthropic.com>
Claude-Session: https://claude.ai/code/session_01McBLtMnJbTnB94NeVs8a2V
</commit_message>
<xml_diff>
--- a/system-design-101/vi/lessons/sd-02-021/slides/sd-02-021.pptx
+++ b/system-design-101/vi/lessons/sd-02-021/slides/sd-02-021.pptx
@@ -12787,6 +12787,39 @@
               <a:buNone/>
             </a:pPr>
             <a:r>
+              <a:rPr lang="en-US" sz="2100" dirty="0" spc="-2" kern="0">
+                <a:solidFill>
+                  <a:srgbClr val="6B6A66"/>
+                </a:solidFill>
+                <a:latin typeface="Be Vietnam Pro" pitchFamily="34" charset="0"/>
+                <a:ea typeface="Be Vietnam Pro" pitchFamily="34" charset="-122"/>
+                <a:cs typeface="Be Vietnam Pro" pitchFamily="34" charset="-120"/>
+              </a:rPr>
+              <a:t>Giả</a:t>
+            </a:r>
+            <a:r>
+              <a:rPr lang="en-US" sz="2100" dirty="0" spc="15" kern="0">
+                <a:solidFill>
+                  <a:srgbClr val="6B6A66"/>
+                </a:solidFill>
+                <a:latin typeface="Be Vietnam Pro" pitchFamily="34" charset="0"/>
+                <a:ea typeface="Be Vietnam Pro" pitchFamily="34" charset="-122"/>
+                <a:cs typeface="Be Vietnam Pro" pitchFamily="34" charset="-120"/>
+              </a:rPr>
+              <a:t> định:</a:t>
+            </a:r>
+            <a:r>
+              <a:rPr lang="en-US" sz="2100" dirty="0" spc="-1" kern="0">
+                <a:solidFill>
+                  <a:srgbClr val="6B6A66"/>
+                </a:solidFill>
+                <a:latin typeface="Be Vietnam Pro" pitchFamily="34" charset="0"/>
+                <a:ea typeface="Be Vietnam Pro" pitchFamily="34" charset="-122"/>
+                <a:cs typeface="Be Vietnam Pro" pitchFamily="34" charset="-120"/>
+              </a:rPr>
+              <a:t> cổng</a:t>
+            </a:r>
+            <a:r>
               <a:rPr lang="en-US" sz="2100" dirty="0" spc="0" kern="0">
                 <a:solidFill>
                   <a:srgbClr val="6B6A66"/>
@@ -12795,7 +12828,7 @@
                 <a:ea typeface="Be Vietnam Pro" pitchFamily="34" charset="-122"/>
                 <a:cs typeface="Be Vietnam Pro" pitchFamily="34" charset="-120"/>
               </a:rPr>
-              <a:t>Cổng chung</a:t>
+              <a:t> chung</a:t>
             </a:r>
             <a:r>
               <a:rPr lang="en-US" sz="2100" dirty="0" spc="-24" kern="0">
@@ -12809,7 +12842,7 @@
               <a:t> trả</a:t>
             </a:r>
             <a:r>
-              <a:rPr lang="en-US" sz="2100" dirty="0" spc="1" kern="0">
+              <a:rPr lang="en-US" sz="2100" dirty="0" spc="0" kern="0">
                 <a:solidFill>
                   <a:srgbClr val="6B6A66"/>
                 </a:solidFill>
@@ -12820,7 +12853,7 @@
               <a:t> cùng</a:t>
             </a:r>
             <a:r>
-              <a:rPr lang="en-US" sz="2100" dirty="0" spc="-9" kern="0">
+              <a:rPr lang="en-US" sz="2100" dirty="0" spc="-8" kern="0">
                 <a:solidFill>
                   <a:srgbClr val="6B6A66"/>
                 </a:solidFill>

</xml_diff>